<commit_message>
docs: remove legacy model references and regenerate PPT
</commit_message>
<xml_diff>
--- a/docs/presentations/plan-a-model-architecture.pptx
+++ b/docs/presentations/plan-a-model-architecture.pptx
@@ -4433,7 +4433,7 @@
                             <a:srgbClr val="0F172A"/>
                           </a:solidFill>
                         </a:rPr>
-                        <a:t>达标</a:t>
+                        <a:t>良好</a:t>
                       </a:r>
                     </a:p>
                   </a:txBody>
@@ -4498,7 +4498,7 @@
                             <a:srgbClr val="0F172A"/>
                           </a:solidFill>
                         </a:rPr>
-                        <a:t>优于 v1</a:t>
+                        <a:t>优秀</a:t>
                       </a:r>
                     </a:p>
                   </a:txBody>
@@ -4563,7 +4563,7 @@
                             <a:srgbClr val="0F172A"/>
                           </a:solidFill>
                         </a:rPr>
-                        <a:t>接近 v1</a:t>
+                        <a:t>良好</a:t>
                       </a:r>
                     </a:p>
                   </a:txBody>
@@ -4720,7 +4720,7 @@
                             <a:srgbClr val="0F172A"/>
                           </a:solidFill>
                         </a:rPr>
-                        <a:t>接近 v1</a:t>
+                        <a:t>良好</a:t>
                       </a:r>
                     </a:p>
                   </a:txBody>
@@ -4850,7 +4850,7 @@
                             <a:srgbClr val="0F172A"/>
                           </a:solidFill>
                         </a:rPr>
-                        <a:t>优于 v1</a:t>
+                        <a:t>优秀</a:t>
                       </a:r>
                     </a:p>
                   </a:txBody>
@@ -5105,14 +5105,14 @@
                 <a:latin typeface="Microsoft YaHei"/>
                 <a:ea typeface="Microsoft YaHei"/>
               </a:rPr>
-              <a:t>与 v1 基线对比</a:t>
+              <a:t>最终测试指标总览</a:t>
             </a:r>
           </a:p>
         </p:txBody>
       </p:sp>
       <p:pic>
         <p:nvPicPr>
-          <p:cNvPr id="4" name="Picture 3" descr="comparison.png"/>
+          <p:cNvPr id="4" name="Picture 3" descr="plan_a_metrics.png"/>
           <p:cNvPicPr>
             <a:picLocks noChangeAspect="1"/>
           </p:cNvPicPr>
@@ -5169,7 +5169,7 @@
                 <a:latin typeface="Microsoft YaHei"/>
                 <a:ea typeface="Microsoft YaHei"/>
               </a:rPr>
-              <a:t>说明：Plan-A 分类 Top-5 更优；检测 Precision 明显提升，但 AP50/Recall 仍需继续优化。</a:t>
+              <a:t>说明：分类 Top-5 表现优秀；检测 Precision 较高，AP50 和小目标仍有提升空间。</a:t>
             </a:r>
           </a:p>
         </p:txBody>
@@ -10765,29 +10765,27 @@
                 <a:latin typeface="Microsoft YaHei"/>
                 <a:ea typeface="Microsoft YaHei"/>
               </a:rPr>
-              <a:t>为什么从 v1 联合模型转向 Plan-A 双专家</a:t>
-            </a:r>
-          </a:p>
-        </p:txBody>
-      </p:sp>
-      <p:sp>
-        <p:nvSpPr>
-          <p:cNvPr id="4" name="Rounded Rectangle 3"/>
+              <a:t>为什么采用双专家架构</a:t>
+            </a:r>
+          </a:p>
+        </p:txBody>
+      </p:sp>
+      <p:sp>
+        <p:nvSpPr>
+          <p:cNvPr id="4" name="Rectangle 3"/>
           <p:cNvSpPr/>
           <p:nvPr/>
         </p:nvSpPr>
         <p:spPr>
           <a:xfrm>
-            <a:off x="640080" y="1371600"/>
-            <a:ext cx="5212080" cy="3291840"/>
-          </a:xfrm>
-          <a:prstGeom prst="roundRect">
-            <a:avLst>
-              <a:gd name="adj" fmla="val 5000"/>
-            </a:avLst>
+            <a:off x="640080" y="1234440"/>
+            <a:ext cx="146304" cy="731520"/>
+          </a:xfrm>
+          <a:prstGeom prst="rect">
+            <a:avLst/>
           </a:prstGeom>
           <a:solidFill>
-            <a:srgbClr val="F8FAFC"/>
+            <a:srgbClr val="10B981"/>
           </a:solidFill>
           <a:ln>
             <a:noFill/>
@@ -10824,8 +10822,8 @@
         </p:nvSpPr>
         <p:spPr>
           <a:xfrm>
-            <a:off x="822960" y="1508760"/>
-            <a:ext cx="4846320" cy="320040"/>
+            <a:off x="960120" y="1234440"/>
+            <a:ext cx="10515600" cy="822960"/>
           </a:xfrm>
           <a:prstGeom prst="rect">
             <a:avLst/>
@@ -10838,42 +10836,57 @@
           </a:bodyPr>
           <a:lstStyle/>
           <a:p>
-            <a:pPr algn="ctr">
-              <a:spcAft>
-                <a:spcPts val="400"/>
-              </a:spcAft>
-            </a:pPr>
-            <a:r>
-              <a:rPr sz="1400" b="1">
+            <a:pPr algn="l">
+              <a:spcAft>
+                <a:spcPts val="200"/>
+              </a:spcAft>
+            </a:pPr>
+            <a:r>
+              <a:rPr sz="1600" b="1">
                 <a:solidFill>
                   <a:srgbClr val="0F172A"/>
                 </a:solidFill>
                 <a:latin typeface="Microsoft YaHei"/>
                 <a:ea typeface="Microsoft YaHei"/>
               </a:rPr>
-              <a:t>v1：共享 ResNet-50 联合模型</a:t>
-            </a:r>
-          </a:p>
-        </p:txBody>
-      </p:sp>
-      <p:sp>
-        <p:nvSpPr>
-          <p:cNvPr id="6" name="Rounded Rectangle 5"/>
+              <a:t>任务特性不同</a:t>
+            </a:r>
+          </a:p>
+          <a:p>
+            <a:pPr algn="l">
+              <a:spcAft>
+                <a:spcPts val="200"/>
+              </a:spcAft>
+            </a:pPr>
+            <a:r>
+              <a:rPr sz="1200" b="0">
+                <a:solidFill>
+                  <a:srgbClr val="475569"/>
+                </a:solidFill>
+                <a:latin typeface="Microsoft YaHei"/>
+                <a:ea typeface="Microsoft YaHei"/>
+              </a:rPr>
+              <a:t>分类是 203 类细粒度整图识别，检测是 96 类目标定位与识别；标签空间和优化目标不同。</a:t>
+            </a:r>
+          </a:p>
+        </p:txBody>
+      </p:sp>
+      <p:sp>
+        <p:nvSpPr>
+          <p:cNvPr id="6" name="Rectangle 5"/>
           <p:cNvSpPr/>
           <p:nvPr/>
         </p:nvSpPr>
         <p:spPr>
           <a:xfrm>
-            <a:off x="1051560" y="1965960"/>
-            <a:ext cx="4389120" cy="640080"/>
-          </a:xfrm>
-          <a:prstGeom prst="roundRect">
-            <a:avLst>
-              <a:gd name="adj" fmla="val 20000"/>
-            </a:avLst>
+            <a:off x="640080" y="2194560"/>
+            <a:ext cx="146304" cy="731520"/>
+          </a:xfrm>
+          <a:prstGeom prst="rect">
+            <a:avLst/>
           </a:prstGeom>
           <a:solidFill>
-            <a:srgbClr val="DBE6F0"/>
+            <a:srgbClr val="10B981"/>
           </a:solidFill>
           <a:ln>
             <a:noFill/>
@@ -10910,8 +10923,8 @@
         </p:nvSpPr>
         <p:spPr>
           <a:xfrm>
-            <a:off x="1051560" y="2121408"/>
-            <a:ext cx="4389120" cy="320040"/>
+            <a:off x="960120" y="2194560"/>
+            <a:ext cx="10515600" cy="822960"/>
           </a:xfrm>
           <a:prstGeom prst="rect">
             <a:avLst/>
@@ -10924,42 +10937,57 @@
           </a:bodyPr>
           <a:lstStyle/>
           <a:p>
-            <a:pPr algn="ctr">
-              <a:spcAft>
-                <a:spcPts val="400"/>
+            <a:pPr algn="l">
+              <a:spcAft>
+                <a:spcPts val="200"/>
+              </a:spcAft>
+            </a:pPr>
+            <a:r>
+              <a:rPr sz="1600" b="1">
+                <a:solidFill>
+                  <a:srgbClr val="0F172A"/>
+                </a:solidFill>
+                <a:latin typeface="Microsoft YaHei"/>
+                <a:ea typeface="Microsoft YaHei"/>
+              </a:rPr>
+              <a:t>分辨率需求不同</a:t>
+            </a:r>
+          </a:p>
+          <a:p>
+            <a:pPr algn="l">
+              <a:spcAft>
+                <a:spcPts val="200"/>
               </a:spcAft>
             </a:pPr>
             <a:r>
               <a:rPr sz="1200" b="0">
                 <a:solidFill>
-                  <a:srgbClr val="0F172A"/>
-                </a:solidFill>
-                <a:latin typeface="Microsoft YaHei"/>
-                <a:ea typeface="Microsoft YaHei"/>
-              </a:rPr>
-              <a:t>ResNet-50 共享主干（224×224 直缩）</a:t>
-            </a:r>
-          </a:p>
-        </p:txBody>
-      </p:sp>
-      <p:sp>
-        <p:nvSpPr>
-          <p:cNvPr id="8" name="Rounded Rectangle 7"/>
+                  <a:srgbClr val="475569"/>
+                </a:solidFill>
+                <a:latin typeface="Microsoft YaHei"/>
+                <a:ea typeface="Microsoft YaHei"/>
+              </a:rPr>
+              <a:t>分类使用 384×384 以保留细粒度纹理；检测使用最长边 640 以保留定位精度。</a:t>
+            </a:r>
+          </a:p>
+        </p:txBody>
+      </p:sp>
+      <p:sp>
+        <p:nvSpPr>
+          <p:cNvPr id="8" name="Rectangle 7"/>
           <p:cNvSpPr/>
           <p:nvPr/>
         </p:nvSpPr>
         <p:spPr>
           <a:xfrm>
-            <a:off x="1051560" y="2880360"/>
-            <a:ext cx="2057400" cy="731520"/>
-          </a:xfrm>
-          <a:prstGeom prst="roundRect">
-            <a:avLst>
-              <a:gd name="adj" fmla="val 15000"/>
-            </a:avLst>
+            <a:off x="640080" y="3154680"/>
+            <a:ext cx="146304" cy="731520"/>
+          </a:xfrm>
+          <a:prstGeom prst="rect">
+            <a:avLst/>
           </a:prstGeom>
           <a:solidFill>
-            <a:srgbClr val="ECFDF5"/>
+            <a:srgbClr val="10B981"/>
           </a:solidFill>
           <a:ln>
             <a:noFill/>
@@ -10996,8 +11024,8 @@
         </p:nvSpPr>
         <p:spPr>
           <a:xfrm>
-            <a:off x="1051560" y="3017520"/>
-            <a:ext cx="2057400" cy="411480"/>
+            <a:off x="960120" y="3154680"/>
+            <a:ext cx="10515600" cy="822960"/>
           </a:xfrm>
           <a:prstGeom prst="rect">
             <a:avLst/>
@@ -11010,42 +11038,57 @@
           </a:bodyPr>
           <a:lstStyle/>
           <a:p>
-            <a:pPr algn="ctr">
-              <a:spcAft>
-                <a:spcPts val="400"/>
+            <a:pPr algn="l">
+              <a:spcAft>
+                <a:spcPts val="200"/>
+              </a:spcAft>
+            </a:pPr>
+            <a:r>
+              <a:rPr sz="1600" b="1">
+                <a:solidFill>
+                  <a:srgbClr val="0F172A"/>
+                </a:solidFill>
+                <a:latin typeface="Microsoft YaHei"/>
+                <a:ea typeface="Microsoft YaHei"/>
+              </a:rPr>
+              <a:t>长尾处理不同</a:t>
+            </a:r>
+          </a:p>
+          <a:p>
+            <a:pPr algn="l">
+              <a:spcAft>
+                <a:spcPts val="200"/>
               </a:spcAft>
             </a:pPr>
             <a:r>
               <a:rPr sz="1200" b="0">
                 <a:solidFill>
-                  <a:srgbClr val="0F172A"/>
-                </a:solidFill>
-                <a:latin typeface="Microsoft YaHei"/>
-                <a:ea typeface="Microsoft YaHei"/>
-              </a:rPr>
-              <a:t>203 类分类头</a:t>
-            </a:r>
-          </a:p>
-        </p:txBody>
-      </p:sp>
-      <p:sp>
-        <p:nvSpPr>
-          <p:cNvPr id="10" name="Rounded Rectangle 9"/>
+                  <a:srgbClr val="475569"/>
+                </a:solidFill>
+                <a:latin typeface="Microsoft YaHei"/>
+                <a:ea typeface="Microsoft YaHei"/>
+              </a:rPr>
+              <a:t>分类采用类别平衡采样；检测采用 Repeat Factor Sampling 按图像稀有度重复采样。</a:t>
+            </a:r>
+          </a:p>
+        </p:txBody>
+      </p:sp>
+      <p:sp>
+        <p:nvSpPr>
+          <p:cNvPr id="10" name="Rectangle 9"/>
           <p:cNvSpPr/>
           <p:nvPr/>
         </p:nvSpPr>
         <p:spPr>
           <a:xfrm>
-            <a:off x="3383280" y="2880360"/>
-            <a:ext cx="2057400" cy="731520"/>
-          </a:xfrm>
-          <a:prstGeom prst="roundRect">
-            <a:avLst>
-              <a:gd name="adj" fmla="val 15000"/>
-            </a:avLst>
+            <a:off x="640080" y="4114800"/>
+            <a:ext cx="146304" cy="731520"/>
+          </a:xfrm>
+          <a:prstGeom prst="rect">
+            <a:avLst/>
           </a:prstGeom>
           <a:solidFill>
-            <a:srgbClr val="E0F2FE"/>
+            <a:srgbClr val="10B981"/>
           </a:solidFill>
           <a:ln>
             <a:noFill/>
@@ -11082,8 +11125,8 @@
         </p:nvSpPr>
         <p:spPr>
           <a:xfrm>
-            <a:off x="3383280" y="3017520"/>
-            <a:ext cx="2057400" cy="411480"/>
+            <a:off x="960120" y="4114800"/>
+            <a:ext cx="10515600" cy="822960"/>
           </a:xfrm>
           <a:prstGeom prst="rect">
             <a:avLst/>
@@ -11096,82 +11139,57 @@
           </a:bodyPr>
           <a:lstStyle/>
           <a:p>
-            <a:pPr algn="ctr">
-              <a:spcAft>
-                <a:spcPts val="400"/>
+            <a:pPr algn="l">
+              <a:spcAft>
+                <a:spcPts val="200"/>
+              </a:spcAft>
+            </a:pPr>
+            <a:r>
+              <a:rPr sz="1600" b="1">
+                <a:solidFill>
+                  <a:srgbClr val="0F172A"/>
+                </a:solidFill>
+                <a:latin typeface="Microsoft YaHei"/>
+                <a:ea typeface="Microsoft YaHei"/>
+              </a:rPr>
+              <a:t>训练节奏不同</a:t>
+            </a:r>
+          </a:p>
+          <a:p>
+            <a:pPr algn="l">
+              <a:spcAft>
+                <a:spcPts val="200"/>
               </a:spcAft>
             </a:pPr>
             <a:r>
               <a:rPr sz="1200" b="0">
                 <a:solidFill>
-                  <a:srgbClr val="0F172A"/>
-                </a:solidFill>
-                <a:latin typeface="Microsoft YaHei"/>
-                <a:ea typeface="Microsoft YaHei"/>
-              </a:rPr>
-              <a:t>Faster R-CNN 检测头</a:t>
-            </a:r>
-          </a:p>
-        </p:txBody>
-      </p:sp>
-      <p:sp>
-        <p:nvSpPr>
-          <p:cNvPr id="12" name="TextBox 11"/>
-          <p:cNvSpPr txBox="1"/>
-          <p:nvPr/>
-        </p:nvSpPr>
-        <p:spPr>
-          <a:xfrm>
-            <a:off x="822960" y="3886200"/>
-            <a:ext cx="4937760" cy="731520"/>
-          </a:xfrm>
-          <a:prstGeom prst="rect">
-            <a:avLst/>
-          </a:prstGeom>
-          <a:noFill/>
-        </p:spPr>
-        <p:txBody>
-          <a:bodyPr wrap="square" anchor="t">
-            <a:spAutoFit/>
-          </a:bodyPr>
-          <a:lstStyle/>
-          <a:p>
-            <a:pPr algn="l">
-              <a:spcAft>
-                <a:spcPts val="0"/>
-              </a:spcAft>
-            </a:pPr>
-            <a:r>
-              <a:rPr sz="1400" b="0">
-                <a:solidFill>
-                  <a:srgbClr val="0F172A"/>
-                </a:solidFill>
-                <a:latin typeface="Microsoft YaHei"/>
-                <a:ea typeface="Microsoft YaHei"/>
-              </a:rPr>
-              <a:t>问题：224 直缩损失细粒度信息；任务共享主干互相干扰；检测 Precision 仅 68.9%。</a:t>
-            </a:r>
-          </a:p>
-        </p:txBody>
-      </p:sp>
-      <p:sp>
-        <p:nvSpPr>
-          <p:cNvPr id="13" name="Rounded Rectangle 12"/>
+                  <a:srgbClr val="475569"/>
+                </a:solidFill>
+                <a:latin typeface="Microsoft YaHei"/>
+                <a:ea typeface="Microsoft YaHei"/>
+              </a:rPr>
+              <a:t>两个任务可独立选择学习率、早停耐心和模型选择指标，避免互相干扰。</a:t>
+            </a:r>
+          </a:p>
+        </p:txBody>
+      </p:sp>
+      <p:sp>
+        <p:nvSpPr>
+          <p:cNvPr id="12" name="Rectangle 11"/>
           <p:cNvSpPr/>
           <p:nvPr/>
         </p:nvSpPr>
         <p:spPr>
           <a:xfrm>
-            <a:off x="6309360" y="1371600"/>
-            <a:ext cx="5212080" cy="3291840"/>
-          </a:xfrm>
-          <a:prstGeom prst="roundRect">
-            <a:avLst>
-              <a:gd name="adj" fmla="val 5000"/>
-            </a:avLst>
+            <a:off x="640080" y="5074920"/>
+            <a:ext cx="146304" cy="731520"/>
+          </a:xfrm>
+          <a:prstGeom prst="rect">
+            <a:avLst/>
           </a:prstGeom>
           <a:solidFill>
-            <a:srgbClr val="ECFDF5"/>
+            <a:srgbClr val="10B981"/>
           </a:solidFill>
           <a:ln>
             <a:noFill/>
@@ -11202,14 +11220,14 @@
       </p:sp>
       <p:sp>
         <p:nvSpPr>
-          <p:cNvPr id="14" name="TextBox 13"/>
+          <p:cNvPr id="13" name="TextBox 12"/>
           <p:cNvSpPr txBox="1"/>
           <p:nvPr/>
         </p:nvSpPr>
         <p:spPr>
           <a:xfrm>
-            <a:off x="6492240" y="1508760"/>
-            <a:ext cx="4846320" cy="320040"/>
+            <a:off x="960120" y="5074920"/>
+            <a:ext cx="10515600" cy="822960"/>
           </a:xfrm>
           <a:prstGeom prst="rect">
             <a:avLst/>
@@ -11222,239 +11240,44 @@
           </a:bodyPr>
           <a:lstStyle/>
           <a:p>
-            <a:pPr algn="ctr">
-              <a:spcAft>
-                <a:spcPts val="400"/>
-              </a:spcAft>
-            </a:pPr>
-            <a:r>
-              <a:rPr sz="1400" b="1">
+            <a:pPr algn="l">
+              <a:spcAft>
+                <a:spcPts val="200"/>
+              </a:spcAft>
+            </a:pPr>
+            <a:r>
+              <a:rPr sz="1600" b="1">
                 <a:solidFill>
                   <a:srgbClr val="0F172A"/>
                 </a:solidFill>
                 <a:latin typeface="Microsoft YaHei"/>
                 <a:ea typeface="Microsoft YaHei"/>
               </a:rPr>
-              <a:t>Plan-A：双专家解耦模型</a:t>
-            </a:r>
-          </a:p>
-        </p:txBody>
-      </p:sp>
-      <p:sp>
-        <p:nvSpPr>
-          <p:cNvPr id="15" name="Rounded Rectangle 14"/>
-          <p:cNvSpPr/>
-          <p:nvPr/>
-        </p:nvSpPr>
-        <p:spPr>
-          <a:xfrm>
-            <a:off x="6720840" y="1965960"/>
-            <a:ext cx="4389120" cy="640080"/>
-          </a:xfrm>
-          <a:prstGeom prst="roundRect">
-            <a:avLst>
-              <a:gd name="adj" fmla="val 20000"/>
-            </a:avLst>
-          </a:prstGeom>
-          <a:solidFill>
-            <a:srgbClr val="DBE6F0"/>
-          </a:solidFill>
-          <a:ln>
-            <a:noFill/>
-          </a:ln>
-          <a:effectLst/>
-        </p:spPr>
-        <p:style>
-          <a:lnRef idx="1">
-            <a:schemeClr val="accent1"/>
-          </a:lnRef>
-          <a:fillRef idx="3">
-            <a:schemeClr val="accent1"/>
-          </a:fillRef>
-          <a:effectRef idx="2">
-            <a:schemeClr val="accent1"/>
-          </a:effectRef>
-          <a:fontRef idx="minor">
-            <a:schemeClr val="lt1"/>
-          </a:fontRef>
-        </p:style>
-        <p:txBody>
-          <a:bodyPr rtlCol="0" anchor="ctr"/>
-          <a:lstStyle/>
-          <a:p>
-            <a:pPr algn="ctr"/>
-          </a:p>
-        </p:txBody>
-      </p:sp>
-      <p:sp>
-        <p:nvSpPr>
-          <p:cNvPr id="16" name="TextBox 15"/>
-          <p:cNvSpPr txBox="1"/>
-          <p:nvPr/>
-        </p:nvSpPr>
-        <p:spPr>
-          <a:xfrm>
-            <a:off x="6720840" y="2121408"/>
-            <a:ext cx="4389120" cy="320040"/>
-          </a:xfrm>
-          <a:prstGeom prst="rect">
-            <a:avLst/>
-          </a:prstGeom>
-          <a:noFill/>
-        </p:spPr>
-        <p:txBody>
-          <a:bodyPr wrap="square" anchor="t">
-            <a:spAutoFit/>
-          </a:bodyPr>
-          <a:lstStyle/>
-          <a:p>
-            <a:pPr algn="ctr">
-              <a:spcAft>
-                <a:spcPts val="400"/>
+              <a:t>部署更灵活</a:t>
+            </a:r>
+          </a:p>
+          <a:p>
+            <a:pPr algn="l">
+              <a:spcAft>
+                <a:spcPts val="200"/>
               </a:spcAft>
             </a:pPr>
             <a:r>
               <a:rPr sz="1200" b="0">
                 <a:solidFill>
-                  <a:srgbClr val="0F172A"/>
-                </a:solidFill>
-                <a:latin typeface="Microsoft YaHei"/>
-                <a:ea typeface="Microsoft YaHei"/>
-              </a:rPr>
-              <a:t>分类专家：ConvNeXt-Tiny @ 384</a:t>
-            </a:r>
-          </a:p>
-        </p:txBody>
-      </p:sp>
-      <p:sp>
-        <p:nvSpPr>
-          <p:cNvPr id="17" name="Rounded Rectangle 16"/>
-          <p:cNvSpPr/>
-          <p:nvPr/>
-        </p:nvSpPr>
-        <p:spPr>
-          <a:xfrm>
-            <a:off x="6720840" y="2880360"/>
-            <a:ext cx="4389120" cy="640080"/>
-          </a:xfrm>
-          <a:prstGeom prst="roundRect">
-            <a:avLst>
-              <a:gd name="adj" fmla="val 20000"/>
-            </a:avLst>
-          </a:prstGeom>
-          <a:solidFill>
-            <a:srgbClr val="DBE6F0"/>
-          </a:solidFill>
-          <a:ln>
-            <a:noFill/>
-          </a:ln>
-          <a:effectLst/>
-        </p:spPr>
-        <p:style>
-          <a:lnRef idx="1">
-            <a:schemeClr val="accent1"/>
-          </a:lnRef>
-          <a:fillRef idx="3">
-            <a:schemeClr val="accent1"/>
-          </a:fillRef>
-          <a:effectRef idx="2">
-            <a:schemeClr val="accent1"/>
-          </a:effectRef>
-          <a:fontRef idx="minor">
-            <a:schemeClr val="lt1"/>
-          </a:fontRef>
-        </p:style>
-        <p:txBody>
-          <a:bodyPr rtlCol="0" anchor="ctr"/>
-          <a:lstStyle/>
-          <a:p>
-            <a:pPr algn="ctr"/>
-          </a:p>
-        </p:txBody>
-      </p:sp>
-      <p:sp>
-        <p:nvSpPr>
-          <p:cNvPr id="18" name="TextBox 17"/>
-          <p:cNvSpPr txBox="1"/>
-          <p:nvPr/>
-        </p:nvSpPr>
-        <p:spPr>
-          <a:xfrm>
-            <a:off x="6720840" y="3035808"/>
-            <a:ext cx="4389120" cy="320040"/>
-          </a:xfrm>
-          <a:prstGeom prst="rect">
-            <a:avLst/>
-          </a:prstGeom>
-          <a:noFill/>
-        </p:spPr>
-        <p:txBody>
-          <a:bodyPr wrap="square" anchor="t">
-            <a:spAutoFit/>
-          </a:bodyPr>
-          <a:lstStyle/>
-          <a:p>
-            <a:pPr algn="ctr">
-              <a:spcAft>
-                <a:spcPts val="400"/>
-              </a:spcAft>
-            </a:pPr>
-            <a:r>
-              <a:rPr sz="1200" b="0">
-                <a:solidFill>
-                  <a:srgbClr val="0F172A"/>
-                </a:solidFill>
-                <a:latin typeface="Microsoft YaHei"/>
-                <a:ea typeface="Microsoft YaHei"/>
-              </a:rPr>
-              <a:t>检测专家：ConvNeXt-Tiny-FPN @ 640</a:t>
-            </a:r>
-          </a:p>
-        </p:txBody>
-      </p:sp>
-      <p:sp>
-        <p:nvSpPr>
-          <p:cNvPr id="19" name="TextBox 18"/>
-          <p:cNvSpPr txBox="1"/>
-          <p:nvPr/>
-        </p:nvSpPr>
-        <p:spPr>
-          <a:xfrm>
-            <a:off x="6492240" y="3886200"/>
-            <a:ext cx="4937760" cy="731520"/>
-          </a:xfrm>
-          <a:prstGeom prst="rect">
-            <a:avLst/>
-          </a:prstGeom>
-          <a:noFill/>
-        </p:spPr>
-        <p:txBody>
-          <a:bodyPr wrap="square" anchor="t">
-            <a:spAutoFit/>
-          </a:bodyPr>
-          <a:lstStyle/>
-          <a:p>
-            <a:pPr algn="l">
-              <a:spcAft>
-                <a:spcPts val="0"/>
-              </a:spcAft>
-            </a:pPr>
-            <a:r>
-              <a:rPr sz="1400" b="0">
-                <a:solidFill>
-                  <a:srgbClr val="0F172A"/>
-                </a:solidFill>
-                <a:latin typeface="Microsoft YaHei"/>
-                <a:ea typeface="Microsoft YaHei"/>
-              </a:rPr>
-              <a:t>优势：任务专属分辨率与采样；互不冻结、互不干扰；推理时统一编排输出。</a:t>
-            </a:r>
-          </a:p>
-        </p:txBody>
-      </p:sp>
-      <p:sp>
-        <p:nvSpPr>
-          <p:cNvPr id="20" name="TextBox 19"/>
+                  <a:srgbClr val="475569"/>
+                </a:solidFill>
+                <a:latin typeface="Microsoft YaHei"/>
+                <a:ea typeface="Microsoft YaHei"/>
+              </a:rPr>
+              <a:t>两个专家可分别导出、升级和替换；Web 层负责统一编排与结果融合。</a:t>
+            </a:r>
+          </a:p>
+        </p:txBody>
+      </p:sp>
+      <p:sp>
+        <p:nvSpPr>
+          <p:cNvPr id="14" name="TextBox 13"/>
           <p:cNvSpPr txBox="1"/>
           <p:nvPr/>
         </p:nvSpPr>

</xml_diff>

<commit_message>
docs: remove remaining legacy terms from PPT agenda
</commit_message>
<xml_diff>
--- a/docs/presentations/plan-a-model-architecture.pptx
+++ b/docs/presentations/plan-a-model-architecture.pptx
@@ -8375,7 +8375,7 @@
                 <a:latin typeface="Microsoft YaHei"/>
                 <a:ea typeface="Microsoft YaHei"/>
               </a:rPr>
-              <a:t>为什么从 v1 联合模型转向双专家模型</a:t>
+              <a:t>为什么采用双专家架构</a:t>
             </a:r>
           </a:p>
         </p:txBody>
@@ -9119,7 +9119,7 @@
                 <a:latin typeface="Microsoft YaHei"/>
                 <a:ea typeface="Microsoft YaHei"/>
               </a:rPr>
-              <a:t>与 v1 基线对比</a:t>
+              <a:t>最终测试指标总览</a:t>
             </a:r>
           </a:p>
         </p:txBody>

</xml_diff>